<commit_message>
Presentation for the project is added
</commit_message>
<xml_diff>
--- a/OmniRecon_Presentation.pptx
+++ b/OmniRecon_Presentation.pptx
@@ -906,49 +906,144 @@
           <a:lstStyle/>
           <a:p>
             <a:r>
+              <a:rPr dirty="0"/>
               <a:t>SPEAKER SCRIPT:</a:t>
             </a:r>
           </a:p>
           <a:p>
             <a:r>
-              <a:t>"Now I want to focus on what I consider the most crucial slide of this presentation: the software engineering architecture behind OmniRecon. For recruiters and engineers, this is where the toolkit truly shines.</a:t>
-            </a:r>
-          </a:p>
-          <a:p>
-            <a:endParaRPr/>
-          </a:p>
-          <a:p>
-            <a:r>
-              <a:t>When building reconnaissance tools, developers often start with standard multi-threading using `ThreadPoolExecutor`. However, OS threads carry heavy memory overhead—4 to 8 megabytes per thread stack—and incur constant kernel context switching. Scaling to hundreds of threads leads to thread starvation and high latency.</a:t>
-            </a:r>
-          </a:p>
-          <a:p>
-            <a:endParaRPr/>
-          </a:p>
-          <a:p>
-            <a:r>
-              <a:t>We solved this by rebuilding OmniRecon around Python's native `asyncio` event loop paired with `aiodns`. `aiodns` interfaces directly with `c-ares`, an asynchronous C-based DNS library. This allows thousands of network queries to run non-blocking on a single operating system thread.</a:t>
-            </a:r>
-          </a:p>
-          <a:p>
-            <a:endParaRPr/>
-          </a:p>
-          <a:p>
-            <a:r>
-              <a:t>However, high concurrency introduces another classic systems challenge: socket exhaustion. If you fire 10,000 DNS queries simultaneously via an unbounded `asyncio.gather()`, your OS crashes with `EMFILE`—Too Many Open Files—and DNS servers drop UDP packets.</a:t>
-            </a:r>
-          </a:p>
-          <a:p>
-            <a:r>
-              <a:t>We resolved this with `asyncio.Semaphore`. The semaphore acts as a gatekeeper, dynamically throttling concurrent connections to a controlled threshold while maintaining maximum saturation.</a:t>
-            </a:r>
-          </a:p>
-          <a:p>
-            <a:endParaRPr/>
-          </a:p>
-          <a:p>
-            <a:r>
-              <a:t>Finally, the entire codebase follows clean code principles: modular engines decoupled via strongly typed dataclasses and verified by a 100% mocked offline test suite utilizing `AsyncMock`."</a:t>
+              <a:rPr dirty="0"/>
+              <a:t>"Now I want to focus on what I consider the most crucial slide of this presentation: the software engineering architecture behind </a:t>
+            </a:r>
+            <a:r>
+              <a:rPr dirty="0" err="1"/>
+              <a:t>OmniRecon</a:t>
+            </a:r>
+            <a:r>
+              <a:rPr dirty="0"/>
+              <a:t>. For recruiters and engineers, this is where the toolkit truly shines.</a:t>
+            </a:r>
+          </a:p>
+          <a:p>
+            <a:endParaRPr dirty="0"/>
+          </a:p>
+          <a:p>
+            <a:r>
+              <a:rPr dirty="0"/>
+              <a:t>When building reconnaissance tools, developers often start with standard multi-threading using `</a:t>
+            </a:r>
+            <a:r>
+              <a:rPr dirty="0" err="1"/>
+              <a:t>ThreadPoolExecutor</a:t>
+            </a:r>
+            <a:r>
+              <a:rPr dirty="0"/>
+              <a:t>`. However, OS threads carry heavy memory overhead—4 to 8 megabytes per thread stack—and incur constant kernel context switching. Scaling to hundreds of threads leads to thread starvation and high latency.</a:t>
+            </a:r>
+          </a:p>
+          <a:p>
+            <a:endParaRPr dirty="0"/>
+          </a:p>
+          <a:p>
+            <a:r>
+              <a:rPr dirty="0"/>
+              <a:t>We solved this by rebuilding </a:t>
+            </a:r>
+            <a:r>
+              <a:rPr dirty="0" err="1"/>
+              <a:t>OmniRecon</a:t>
+            </a:r>
+            <a:r>
+              <a:rPr dirty="0"/>
+              <a:t> around Python's native `</a:t>
+            </a:r>
+            <a:r>
+              <a:rPr dirty="0" err="1"/>
+              <a:t>asyncio</a:t>
+            </a:r>
+            <a:r>
+              <a:rPr dirty="0"/>
+              <a:t>` event loop paired with `</a:t>
+            </a:r>
+            <a:r>
+              <a:rPr dirty="0" err="1"/>
+              <a:t>aiodns</a:t>
+            </a:r>
+            <a:r>
+              <a:rPr dirty="0"/>
+              <a:t>`. `</a:t>
+            </a:r>
+            <a:r>
+              <a:rPr dirty="0" err="1"/>
+              <a:t>aiodns</a:t>
+            </a:r>
+            <a:r>
+              <a:rPr dirty="0"/>
+              <a:t>` interfaces directly with `c-</a:t>
+            </a:r>
+            <a:r>
+              <a:rPr dirty="0" err="1"/>
+              <a:t>ares</a:t>
+            </a:r>
+            <a:r>
+              <a:rPr dirty="0"/>
+              <a:t>`, an asynchronous C-based DNS library. This allows thousands of network queries to run non-blocking on a single operating system thread.</a:t>
+            </a:r>
+          </a:p>
+          <a:p>
+            <a:endParaRPr dirty="0"/>
+          </a:p>
+          <a:p>
+            <a:r>
+              <a:rPr dirty="0"/>
+              <a:t>However, high concurrency introduces another classic systems challenge: socket exhaustion. If you fire 10,000 DNS queries simultaneously via an unbounded `</a:t>
+            </a:r>
+            <a:r>
+              <a:rPr dirty="0" err="1"/>
+              <a:t>asyncio.gather</a:t>
+            </a:r>
+            <a:r>
+              <a:rPr dirty="0"/>
+              <a:t>()`, your OS crashes with `EMFILE`—Too Many Open Files—and DNS servers drop UDP packets.</a:t>
+            </a:r>
+          </a:p>
+          <a:p>
+            <a:r>
+              <a:rPr dirty="0"/>
+              <a:t>We resolved this with `</a:t>
+            </a:r>
+            <a:r>
+              <a:rPr dirty="0" err="1"/>
+              <a:t>asyncio.Semaphore</a:t>
+            </a:r>
+            <a:r>
+              <a:rPr dirty="0"/>
+              <a:t>`. The semaphore acts as a gatekeeper, dynamically throttling concurrent connections to a controlled threshold while maintaining maximum saturation.</a:t>
+            </a:r>
+          </a:p>
+          <a:p>
+            <a:endParaRPr dirty="0"/>
+          </a:p>
+          <a:p>
+            <a:r>
+              <a:rPr dirty="0"/>
+              <a:t>Finally, the entire codebase follows clean code principles: modular engines decoupled via strongly typed </a:t>
+            </a:r>
+            <a:r>
+              <a:rPr dirty="0" err="1"/>
+              <a:t>dataclasses</a:t>
+            </a:r>
+            <a:r>
+              <a:rPr dirty="0"/>
+              <a:t> and verified by a 100% mocked offline test suite utilizing `</a:t>
+            </a:r>
+            <a:r>
+              <a:rPr dirty="0" err="1"/>
+              <a:t>AsyncMock</a:t>
+            </a:r>
+            <a:r>
+              <a:rPr dirty="0"/>
+              <a:t>`."</a:t>
             </a:r>
           </a:p>
         </p:txBody>
@@ -5022,8 +5117,8 @@
         </p:nvSpPr>
         <p:spPr>
           <a:xfrm>
-            <a:off x="960120" y="1828800"/>
-            <a:ext cx="4754880" cy="502920"/>
+            <a:off x="1219201" y="1944921"/>
+            <a:ext cx="4754880" cy="415498"/>
           </a:xfrm>
           <a:prstGeom prst="rect">
             <a:avLst/>
@@ -5045,10 +5140,22 @@
               </a:defRPr>
             </a:pPr>
             <a:r>
+              <a:rPr dirty="0"/>
               <a:t>[THE CAUSE] </a:t>
             </a:r>
-            <a:r>
-              <a:rPr sz="1600" b="1">
+            <a:endParaRPr lang="en-IN" dirty="0"/>
+          </a:p>
+          <a:p>
+            <a:pPr>
+              <a:defRPr sz="1100" b="1">
+                <a:solidFill>
+                  <a:srgbClr val="FFB300"/>
+                </a:solidFill>
+                <a:latin typeface="Consolas"/>
+              </a:defRPr>
+            </a:pPr>
+            <a:r>
+              <a:rPr sz="1600" b="1" dirty="0">
                 <a:solidFill>
                   <a:srgbClr val="FFFFFF"/>
                 </a:solidFill>
@@ -5067,7 +5174,7 @@
         </p:nvSpPr>
         <p:spPr>
           <a:xfrm>
-            <a:off x="960120" y="2286000"/>
+            <a:off x="960120" y="2514600"/>
             <a:ext cx="4754880" cy="2971799"/>
           </a:xfrm>
           <a:prstGeom prst="rect">
@@ -5087,7 +5194,7 @@
               </a:spcAft>
             </a:pPr>
             <a:r>
-              <a:rPr sz="1200" b="1">
+              <a:rPr sz="1200" b="1" dirty="0">
                 <a:solidFill>
                   <a:srgbClr val="FFB300"/>
                 </a:solidFill>
@@ -5096,7 +5203,7 @@
               <a:t>▸ </a:t>
             </a:r>
             <a:r>
-              <a:rPr sz="1200" b="1">
+              <a:rPr sz="1200" b="1" dirty="0">
                 <a:solidFill>
                   <a:srgbClr val="FFFFFF"/>
                 </a:solidFill>
@@ -5105,7 +5212,7 @@
               <a:t>Cloud &amp; Microservice Sprawl: </a:t>
             </a:r>
             <a:r>
-              <a:rPr sz="1200">
+              <a:rPr sz="1200" dirty="0">
                 <a:solidFill>
                   <a:srgbClr val="BAC9E0"/>
                 </a:solidFill>
@@ -5121,7 +5228,7 @@
               </a:spcAft>
             </a:pPr>
             <a:r>
-              <a:rPr sz="1200" b="1">
+              <a:rPr sz="1200" b="1" dirty="0">
                 <a:solidFill>
                   <a:srgbClr val="FFB300"/>
                 </a:solidFill>
@@ -5130,7 +5237,7 @@
               <a:t>▸ </a:t>
             </a:r>
             <a:r>
-              <a:rPr sz="1200" b="1">
+              <a:rPr sz="1200" b="1" dirty="0">
                 <a:solidFill>
                   <a:srgbClr val="FFFFFF"/>
                 </a:solidFill>
@@ -5139,13 +5246,31 @@
               <a:t>Shadow IT &amp; Staging Leaks: </a:t>
             </a:r>
             <a:r>
-              <a:rPr sz="1200">
-                <a:solidFill>
-                  <a:srgbClr val="BAC9E0"/>
-                </a:solidFill>
-                <a:latin typeface="Calibri"/>
-              </a:rPr>
-              <a:t>Dev teams create temporary testing subdomains (`dev-auth`, `staging-api`) that remain live indefinitely.</a:t>
+              <a:rPr sz="1200" dirty="0">
+                <a:solidFill>
+                  <a:srgbClr val="BAC9E0"/>
+                </a:solidFill>
+                <a:latin typeface="Calibri"/>
+              </a:rPr>
+              <a:t>Dev teams create temporary testing subdomains (`dev-auth`, `staging-</a:t>
+            </a:r>
+            <a:r>
+              <a:rPr sz="1200" dirty="0" err="1">
+                <a:solidFill>
+                  <a:srgbClr val="BAC9E0"/>
+                </a:solidFill>
+                <a:latin typeface="Calibri"/>
+              </a:rPr>
+              <a:t>api</a:t>
+            </a:r>
+            <a:r>
+              <a:rPr sz="1200" dirty="0">
+                <a:solidFill>
+                  <a:srgbClr val="BAC9E0"/>
+                </a:solidFill>
+                <a:latin typeface="Calibri"/>
+              </a:rPr>
+              <a:t>`) that remain live indefinitely.</a:t>
             </a:r>
           </a:p>
           <a:p>
@@ -5155,7 +5280,7 @@
               </a:spcAft>
             </a:pPr>
             <a:r>
-              <a:rPr sz="1200" b="1">
+              <a:rPr sz="1200" b="1" dirty="0">
                 <a:solidFill>
                   <a:srgbClr val="FFB300"/>
                 </a:solidFill>
@@ -5164,7 +5289,7 @@
               <a:t>▸ </a:t>
             </a:r>
             <a:r>
-              <a:rPr sz="1200" b="1">
+              <a:rPr sz="1200" b="1" dirty="0">
                 <a:solidFill>
                   <a:srgbClr val="FFFFFF"/>
                 </a:solidFill>
@@ -5173,7 +5298,7 @@
               <a:t>M&amp;A Infrastructure Blind Spots: </a:t>
             </a:r>
             <a:r>
-              <a:rPr sz="1200">
+              <a:rPr sz="1200" dirty="0">
                 <a:solidFill>
                   <a:srgbClr val="BAC9E0"/>
                 </a:solidFill>
@@ -5189,7 +5314,7 @@
               </a:spcAft>
             </a:pPr>
             <a:r>
-              <a:rPr sz="1200" b="1">
+              <a:rPr sz="1200" b="1" dirty="0">
                 <a:solidFill>
                   <a:srgbClr val="FFB300"/>
                 </a:solidFill>
@@ -5198,7 +5323,7 @@
               <a:t>▸ </a:t>
             </a:r>
             <a:r>
-              <a:rPr sz="1200" b="1">
+              <a:rPr sz="1200" b="1" dirty="0">
                 <a:solidFill>
                   <a:srgbClr val="FFFFFF"/>
                 </a:solidFill>
@@ -5207,7 +5332,7 @@
               <a:t>Outdated Static Inventory: </a:t>
             </a:r>
             <a:r>
-              <a:rPr sz="1200">
+              <a:rPr sz="1200" dirty="0">
                 <a:solidFill>
                   <a:srgbClr val="BAC9E0"/>
                 </a:solidFill>
@@ -5272,8 +5397,8 @@
         </p:nvSpPr>
         <p:spPr>
           <a:xfrm>
-            <a:off x="6446520" y="1828800"/>
-            <a:ext cx="4754880" cy="502920"/>
+            <a:off x="6675120" y="1949778"/>
+            <a:ext cx="4754880" cy="415498"/>
           </a:xfrm>
           <a:prstGeom prst="rect">
             <a:avLst/>
@@ -5295,10 +5420,22 @@
               </a:defRPr>
             </a:pPr>
             <a:r>
+              <a:rPr dirty="0"/>
               <a:t>[THE EXPLOITATION] </a:t>
             </a:r>
-            <a:r>
-              <a:rPr sz="1600" b="1">
+            <a:endParaRPr lang="en-IN" dirty="0"/>
+          </a:p>
+          <a:p>
+            <a:pPr>
+              <a:defRPr sz="1100" b="1">
+                <a:solidFill>
+                  <a:srgbClr val="FF4081"/>
+                </a:solidFill>
+                <a:latin typeface="Consolas"/>
+              </a:defRPr>
+            </a:pPr>
+            <a:r>
+              <a:rPr sz="1600" b="1" dirty="0">
                 <a:solidFill>
                   <a:srgbClr val="FFFFFF"/>
                 </a:solidFill>
@@ -5317,7 +5454,7 @@
         </p:nvSpPr>
         <p:spPr>
           <a:xfrm>
-            <a:off x="6446520" y="2286000"/>
+            <a:off x="6446520" y="2514600"/>
             <a:ext cx="4754880" cy="2971799"/>
           </a:xfrm>
           <a:prstGeom prst="rect">
@@ -5337,7 +5474,7 @@
               </a:spcAft>
             </a:pPr>
             <a:r>
-              <a:rPr sz="1200" b="1">
+              <a:rPr sz="1200" b="1" dirty="0">
                 <a:solidFill>
                   <a:srgbClr val="FF4081"/>
                 </a:solidFill>
@@ -5346,7 +5483,7 @@
               <a:t>▸ </a:t>
             </a:r>
             <a:r>
-              <a:rPr sz="1200" b="1">
+              <a:rPr sz="1200" b="1" dirty="0">
                 <a:solidFill>
                   <a:srgbClr val="FFFFFF"/>
                 </a:solidFill>
@@ -5355,7 +5492,7 @@
               <a:t>Dangling DNS Pointers: </a:t>
             </a:r>
             <a:r>
-              <a:rPr sz="1200">
+              <a:rPr sz="1200" dirty="0">
                 <a:solidFill>
                   <a:srgbClr val="BAC9E0"/>
                 </a:solidFill>
@@ -5371,7 +5508,7 @@
               </a:spcAft>
             </a:pPr>
             <a:r>
-              <a:rPr sz="1200" b="1">
+              <a:rPr sz="1200" b="1" dirty="0">
                 <a:solidFill>
                   <a:srgbClr val="FF4081"/>
                 </a:solidFill>
@@ -5380,7 +5517,7 @@
               <a:t>▸ </a:t>
             </a:r>
             <a:r>
-              <a:rPr sz="1200" b="1">
+              <a:rPr sz="1200" b="1" dirty="0">
                 <a:solidFill>
                   <a:srgbClr val="FFFFFF"/>
                 </a:solidFill>
@@ -5389,7 +5526,7 @@
               <a:t>Subdomain Takeover: </a:t>
             </a:r>
             <a:r>
-              <a:rPr sz="1200">
+              <a:rPr sz="1200" dirty="0">
                 <a:solidFill>
                   <a:srgbClr val="BAC9E0"/>
                 </a:solidFill>
@@ -5405,7 +5542,7 @@
               </a:spcAft>
             </a:pPr>
             <a:r>
-              <a:rPr sz="1200" b="1">
+              <a:rPr sz="1200" b="1" dirty="0">
                 <a:solidFill>
                   <a:srgbClr val="FF4081"/>
                 </a:solidFill>
@@ -5414,7 +5551,7 @@
               <a:t>▸ </a:t>
             </a:r>
             <a:r>
-              <a:rPr sz="1200" b="1">
+              <a:rPr sz="1200" b="1" dirty="0">
                 <a:solidFill>
                   <a:srgbClr val="FFFFFF"/>
                 </a:solidFill>
@@ -5423,7 +5560,7 @@
               <a:t>Unpatched Legacy Services: </a:t>
             </a:r>
             <a:r>
-              <a:rPr sz="1200">
+              <a:rPr sz="1200" dirty="0">
                 <a:solidFill>
                   <a:srgbClr val="BAC9E0"/>
                 </a:solidFill>
@@ -5439,7 +5576,7 @@
               </a:spcAft>
             </a:pPr>
             <a:r>
-              <a:rPr sz="1200" b="1">
+              <a:rPr sz="1200" b="1" dirty="0">
                 <a:solidFill>
                   <a:srgbClr val="FF4081"/>
                 </a:solidFill>
@@ -5448,7 +5585,7 @@
               <a:t>▸ </a:t>
             </a:r>
             <a:r>
-              <a:rPr sz="1200" b="1">
+              <a:rPr sz="1200" b="1" dirty="0">
                 <a:solidFill>
                   <a:srgbClr val="FFFFFF"/>
                 </a:solidFill>
@@ -5457,7 +5594,7 @@
               <a:t>Credential Leaks via TXT: </a:t>
             </a:r>
             <a:r>
-              <a:rPr sz="1200">
+              <a:rPr sz="1200" dirty="0">
                 <a:solidFill>
                   <a:srgbClr val="BAC9E0"/>
                 </a:solidFill>
@@ -7856,7 +7993,7 @@
         </p:nvSpPr>
         <p:spPr>
           <a:xfrm>
-            <a:off x="960120" y="2286000"/>
+            <a:off x="960120" y="2487547"/>
             <a:ext cx="4754880" cy="2971799"/>
           </a:xfrm>
           <a:prstGeom prst="rect">
@@ -7876,7 +8013,7 @@
               </a:spcAft>
             </a:pPr>
             <a:r>
-              <a:rPr sz="1200" b="1">
+              <a:rPr sz="1200" b="1" dirty="0">
                 <a:solidFill>
                   <a:srgbClr val="00E5FF"/>
                 </a:solidFill>
@@ -7885,7 +8022,7 @@
               <a:t>▸ </a:t>
             </a:r>
             <a:r>
-              <a:rPr sz="1200" b="1">
+              <a:rPr sz="1200" b="1" dirty="0">
                 <a:solidFill>
                   <a:srgbClr val="FFFFFF"/>
                 </a:solidFill>
@@ -7894,7 +8031,7 @@
               <a:t>RFC 6962 Public Audit Logs: </a:t>
             </a:r>
             <a:r>
-              <a:rPr sz="1200">
+              <a:rPr sz="1200" dirty="0">
                 <a:solidFill>
                   <a:srgbClr val="BAC9E0"/>
                 </a:solidFill>
@@ -7910,7 +8047,7 @@
               </a:spcAft>
             </a:pPr>
             <a:r>
-              <a:rPr sz="1200" b="1">
+              <a:rPr sz="1200" b="1" dirty="0">
                 <a:solidFill>
                   <a:srgbClr val="00E5FF"/>
                 </a:solidFill>
@@ -7919,7 +8056,7 @@
               <a:t>▸ </a:t>
             </a:r>
             <a:r>
-              <a:rPr sz="1200" b="1">
+              <a:rPr sz="1200" b="1" dirty="0">
                 <a:solidFill>
                   <a:srgbClr val="FFFFFF"/>
                 </a:solidFill>
@@ -7928,7 +8065,7 @@
               <a:t>Target Undetectable: </a:t>
             </a:r>
             <a:r>
-              <a:rPr sz="1200">
+              <a:rPr sz="1200" dirty="0">
                 <a:solidFill>
                   <a:srgbClr val="BAC9E0"/>
                 </a:solidFill>
@@ -7944,7 +8081,7 @@
               </a:spcAft>
             </a:pPr>
             <a:r>
-              <a:rPr sz="1200" b="1">
+              <a:rPr sz="1200" b="1" dirty="0">
                 <a:solidFill>
                   <a:srgbClr val="00E5FF"/>
                 </a:solidFill>
@@ -7953,7 +8090,7 @@
               <a:t>▸ </a:t>
             </a:r>
             <a:r>
-              <a:rPr sz="1200" b="1">
+              <a:rPr sz="1200" b="1" dirty="0">
                 <a:solidFill>
                   <a:srgbClr val="FFFFFF"/>
                 </a:solidFill>
@@ -7962,7 +8099,7 @@
               <a:t>Historical Asset Discovery: </a:t>
             </a:r>
             <a:r>
-              <a:rPr sz="1200">
+              <a:rPr sz="1200" dirty="0">
                 <a:solidFill>
                   <a:srgbClr val="BAC9E0"/>
                 </a:solidFill>
@@ -7978,7 +8115,7 @@
               </a:spcAft>
             </a:pPr>
             <a:r>
-              <a:rPr sz="1200" b="1">
+              <a:rPr sz="1200" b="1" dirty="0">
                 <a:solidFill>
                   <a:srgbClr val="00E5FF"/>
                 </a:solidFill>
@@ -7987,7 +8124,7 @@
               <a:t>▸ </a:t>
             </a:r>
             <a:r>
-              <a:rPr sz="1200" b="1">
+              <a:rPr sz="1200" b="1" dirty="0">
                 <a:solidFill>
                   <a:srgbClr val="FFFFFF"/>
                 </a:solidFill>
@@ -7996,7 +8133,7 @@
               <a:t>Instant Seed Generation: </a:t>
             </a:r>
             <a:r>
-              <a:rPr sz="1200">
+              <a:rPr sz="1200" dirty="0">
                 <a:solidFill>
                   <a:srgbClr val="BAC9E0"/>
                 </a:solidFill>
@@ -8106,7 +8243,7 @@
         </p:nvSpPr>
         <p:spPr>
           <a:xfrm>
-            <a:off x="6446520" y="2286000"/>
+            <a:off x="6446520" y="2482200"/>
             <a:ext cx="4754880" cy="2971799"/>
           </a:xfrm>
           <a:prstGeom prst="rect">
@@ -8126,7 +8263,7 @@
               </a:spcAft>
             </a:pPr>
             <a:r>
-              <a:rPr sz="1200" b="1">
+              <a:rPr sz="1200" b="1" dirty="0">
                 <a:solidFill>
                   <a:srgbClr val="00E676"/>
                 </a:solidFill>
@@ -8135,7 +8272,7 @@
               <a:t>▸ </a:t>
             </a:r>
             <a:r>
-              <a:rPr sz="1200" b="1">
+              <a:rPr sz="1200" b="1" dirty="0">
                 <a:solidFill>
                   <a:srgbClr val="FFFFFF"/>
                 </a:solidFill>
@@ -8144,13 +8281,49 @@
               <a:t>High-Probability Wordlists: </a:t>
             </a:r>
             <a:r>
-              <a:rPr sz="1200">
-                <a:solidFill>
-                  <a:srgbClr val="BAC9E0"/>
-                </a:solidFill>
-                <a:latin typeface="Calibri"/>
-              </a:rPr>
-              <a:t>Brute-forces standard infrastructure names: `api`, `vpn`, `dev`, `admin`, `internal`, `s3`.</a:t>
+              <a:rPr sz="1200" dirty="0">
+                <a:solidFill>
+                  <a:srgbClr val="BAC9E0"/>
+                </a:solidFill>
+                <a:latin typeface="Calibri"/>
+              </a:rPr>
+              <a:t>Brute-forces standard infrastructure names: `</a:t>
+            </a:r>
+            <a:r>
+              <a:rPr sz="1200" dirty="0" err="1">
+                <a:solidFill>
+                  <a:srgbClr val="BAC9E0"/>
+                </a:solidFill>
+                <a:latin typeface="Calibri"/>
+              </a:rPr>
+              <a:t>api</a:t>
+            </a:r>
+            <a:r>
+              <a:rPr sz="1200" dirty="0">
+                <a:solidFill>
+                  <a:srgbClr val="BAC9E0"/>
+                </a:solidFill>
+                <a:latin typeface="Calibri"/>
+              </a:rPr>
+              <a:t>`, `</a:t>
+            </a:r>
+            <a:r>
+              <a:rPr sz="1200" dirty="0" err="1">
+                <a:solidFill>
+                  <a:srgbClr val="BAC9E0"/>
+                </a:solidFill>
+                <a:latin typeface="Calibri"/>
+              </a:rPr>
+              <a:t>vpn</a:t>
+            </a:r>
+            <a:r>
+              <a:rPr sz="1200" dirty="0">
+                <a:solidFill>
+                  <a:srgbClr val="BAC9E0"/>
+                </a:solidFill>
+                <a:latin typeface="Calibri"/>
+              </a:rPr>
+              <a:t>`, `dev`, `admin`, `internal`, `s3`.</a:t>
             </a:r>
           </a:p>
           <a:p>
@@ -8160,7 +8333,7 @@
               </a:spcAft>
             </a:pPr>
             <a:r>
-              <a:rPr sz="1200" b="1">
+              <a:rPr sz="1200" b="1" dirty="0">
                 <a:solidFill>
                   <a:srgbClr val="00E676"/>
                 </a:solidFill>
@@ -8169,7 +8342,7 @@
               <a:t>▸ </a:t>
             </a:r>
             <a:r>
-              <a:rPr sz="1200" b="1">
+              <a:rPr sz="1200" b="1" dirty="0">
                 <a:solidFill>
                   <a:srgbClr val="FFFFFF"/>
                 </a:solidFill>
@@ -8178,13 +8351,31 @@
               <a:t>Asynchronous DNS Resolution: </a:t>
             </a:r>
             <a:r>
-              <a:rPr sz="1200">
-                <a:solidFill>
-                  <a:srgbClr val="BAC9E0"/>
-                </a:solidFill>
-                <a:latin typeface="Calibri"/>
-              </a:rPr>
-              <a:t>Utilizes `aiodns` and Python's event loop to resolve hundreds of subdomains concurrently.</a:t>
+              <a:rPr sz="1200" dirty="0">
+                <a:solidFill>
+                  <a:srgbClr val="BAC9E0"/>
+                </a:solidFill>
+                <a:latin typeface="Calibri"/>
+              </a:rPr>
+              <a:t>Utilizes `</a:t>
+            </a:r>
+            <a:r>
+              <a:rPr sz="1200" dirty="0" err="1">
+                <a:solidFill>
+                  <a:srgbClr val="BAC9E0"/>
+                </a:solidFill>
+                <a:latin typeface="Calibri"/>
+              </a:rPr>
+              <a:t>aiodns</a:t>
+            </a:r>
+            <a:r>
+              <a:rPr sz="1200" dirty="0">
+                <a:solidFill>
+                  <a:srgbClr val="BAC9E0"/>
+                </a:solidFill>
+                <a:latin typeface="Calibri"/>
+              </a:rPr>
+              <a:t>` and Python's event loop to resolve hundreds of subdomains concurrently.</a:t>
             </a:r>
           </a:p>
           <a:p>
@@ -8194,7 +8385,7 @@
               </a:spcAft>
             </a:pPr>
             <a:r>
-              <a:rPr sz="1200" b="1">
+              <a:rPr sz="1200" b="1" dirty="0">
                 <a:solidFill>
                   <a:srgbClr val="00E676"/>
                 </a:solidFill>
@@ -8203,7 +8394,7 @@
               <a:t>▸ </a:t>
             </a:r>
             <a:r>
-              <a:rPr sz="1200" b="1">
+              <a:rPr sz="1200" b="1" dirty="0">
                 <a:solidFill>
                   <a:srgbClr val="FFFFFF"/>
                 </a:solidFill>
@@ -8212,7 +8403,7 @@
               <a:t>Asynchronous Wildcard Immunity: </a:t>
             </a:r>
             <a:r>
-              <a:rPr sz="1200">
+              <a:rPr sz="1200" dirty="0">
                 <a:solidFill>
                   <a:srgbClr val="BAC9E0"/>
                 </a:solidFill>
@@ -8228,7 +8419,7 @@
               </a:spcAft>
             </a:pPr>
             <a:r>
-              <a:rPr sz="1200" b="1">
+              <a:rPr sz="1200" b="1" dirty="0">
                 <a:solidFill>
                   <a:srgbClr val="00E676"/>
                 </a:solidFill>
@@ -8237,7 +8428,7 @@
               <a:t>▸ </a:t>
             </a:r>
             <a:r>
-              <a:rPr sz="1200" b="1">
+              <a:rPr sz="1200" b="1" dirty="0">
                 <a:solidFill>
                   <a:srgbClr val="FFFFFF"/>
                 </a:solidFill>
@@ -8246,7 +8437,7 @@
               <a:t>Resolved Asset Union: </a:t>
             </a:r>
             <a:r>
-              <a:rPr sz="1200">
+              <a:rPr sz="1200" dirty="0">
                 <a:solidFill>
                   <a:srgbClr val="BAC9E0"/>
                 </a:solidFill>

</xml_diff>

<commit_message>
Made some changes to the power point presentation
</commit_message>
<xml_diff>
--- a/OmniRecon_Presentation.pptx
+++ b/OmniRecon_Presentation.pptx
@@ -304,28 +304,56 @@
           <a:lstStyle/>
           <a:p>
             <a:r>
+              <a:rPr dirty="0"/>
               <a:t>SPEAKER SCRIPT:</a:t>
             </a:r>
           </a:p>
           <a:p>
             <a:r>
-              <a:t>"Good morning, esteemed committee members and recruiters. My name is Deepakraj S, and today I am excited to present OmniRecon: a high-performance, asynchronous reconnaissance toolkit and external attack surface management engine.</a:t>
-            </a:r>
-          </a:p>
-          <a:p>
-            <a:endParaRPr/>
-          </a:p>
-          <a:p>
-            <a:r>
-              <a:t>In modern cybersecurity, you cannot defend what you don't know exists. OmniRecon addresses a fundamental challenge: how modern enterprises lose track of their exposed infrastructure. </a:t>
-            </a:r>
-          </a:p>
-          <a:p>
-            <a:endParaRPr/>
-          </a:p>
-          <a:p>
-            <a:r>
-              <a:t>Equally important to the security problem is how it was engineered. Today, we will examine both the offensive cybersecurity mechanics and the backend systems architecture—specifically why we transitioned away from blocking threads to a high-throughput AsyncIO event loop with non-blocking DNS and HTTP probers. Let's dive in."</a:t>
+              <a:rPr dirty="0"/>
+              <a:t>"My name is Deepakraj S, and today I am excited to present </a:t>
+            </a:r>
+            <a:r>
+              <a:rPr dirty="0" err="1"/>
+              <a:t>OmniRecon</a:t>
+            </a:r>
+            <a:r>
+              <a:rPr dirty="0"/>
+              <a:t>: a high-performance, asynchronous reconnaissance toolkit and external attack surface management engine.</a:t>
+            </a:r>
+          </a:p>
+          <a:p>
+            <a:endParaRPr dirty="0"/>
+          </a:p>
+          <a:p>
+            <a:r>
+              <a:rPr dirty="0"/>
+              <a:t>In modern cybersecurity, you cannot defend what you don't know exists. </a:t>
+            </a:r>
+            <a:r>
+              <a:rPr dirty="0" err="1"/>
+              <a:t>OmniRecon</a:t>
+            </a:r>
+            <a:r>
+              <a:rPr dirty="0"/>
+              <a:t> addresses a fundamental challenge: how modern enterprises lose track of their exposed infrastructure. </a:t>
+            </a:r>
+          </a:p>
+          <a:p>
+            <a:endParaRPr dirty="0"/>
+          </a:p>
+          <a:p>
+            <a:r>
+              <a:rPr dirty="0"/>
+              <a:t>Equally important to the security problem is how it was engineered. Today, we will examine both the offensive cybersecurity mechanics and the backend systems architecture—specifically why we transitioned away from blocking threads to a high-throughput </a:t>
+            </a:r>
+            <a:r>
+              <a:rPr dirty="0" err="1"/>
+              <a:t>AsyncIO</a:t>
+            </a:r>
+            <a:r>
+              <a:rPr dirty="0"/>
+              <a:t> event loop with non-blocking DNS and HTTP probers. Let's dive in."</a:t>
             </a:r>
           </a:p>
         </p:txBody>
@@ -1445,7 +1473,7 @@
           <a:p>
             <a:fld id="{5BCAD085-E8A6-8845-BD4E-CB4CCA059FC4}" type="datetimeFigureOut">
               <a:rPr lang="en-US" smtClean="0"/>
-              <a:t>10/6/2026</a:t>
+              <a:t>10/8/2026</a:t>
             </a:fld>
             <a:endParaRPr lang="en-US"/>
           </a:p>
@@ -1613,7 +1641,7 @@
           <a:p>
             <a:fld id="{5BCAD085-E8A6-8845-BD4E-CB4CCA059FC4}" type="datetimeFigureOut">
               <a:rPr lang="en-US" smtClean="0"/>
-              <a:t>10/6/2026</a:t>
+              <a:t>10/8/2026</a:t>
             </a:fld>
             <a:endParaRPr lang="en-US"/>
           </a:p>
@@ -1791,7 +1819,7 @@
           <a:p>
             <a:fld id="{5BCAD085-E8A6-8845-BD4E-CB4CCA059FC4}" type="datetimeFigureOut">
               <a:rPr lang="en-US" smtClean="0"/>
-              <a:t>10/6/2026</a:t>
+              <a:t>10/8/2026</a:t>
             </a:fld>
             <a:endParaRPr lang="en-US"/>
           </a:p>
@@ -1959,7 +1987,7 @@
           <a:p>
             <a:fld id="{5BCAD085-E8A6-8845-BD4E-CB4CCA059FC4}" type="datetimeFigureOut">
               <a:rPr lang="en-US" smtClean="0"/>
-              <a:t>10/6/2026</a:t>
+              <a:t>10/8/2026</a:t>
             </a:fld>
             <a:endParaRPr lang="en-US"/>
           </a:p>
@@ -2204,7 +2232,7 @@
           <a:p>
             <a:fld id="{5BCAD085-E8A6-8845-BD4E-CB4CCA059FC4}" type="datetimeFigureOut">
               <a:rPr lang="en-US" smtClean="0"/>
-              <a:t>10/6/2026</a:t>
+              <a:t>10/8/2026</a:t>
             </a:fld>
             <a:endParaRPr lang="en-US"/>
           </a:p>
@@ -2489,7 +2517,7 @@
           <a:p>
             <a:fld id="{5BCAD085-E8A6-8845-BD4E-CB4CCA059FC4}" type="datetimeFigureOut">
               <a:rPr lang="en-US" smtClean="0"/>
-              <a:t>10/6/2026</a:t>
+              <a:t>10/8/2026</a:t>
             </a:fld>
             <a:endParaRPr lang="en-US"/>
           </a:p>
@@ -2908,7 +2936,7 @@
           <a:p>
             <a:fld id="{5BCAD085-E8A6-8845-BD4E-CB4CCA059FC4}" type="datetimeFigureOut">
               <a:rPr lang="en-US" smtClean="0"/>
-              <a:t>10/6/2026</a:t>
+              <a:t>10/8/2026</a:t>
             </a:fld>
             <a:endParaRPr lang="en-US"/>
           </a:p>
@@ -3025,7 +3053,7 @@
           <a:p>
             <a:fld id="{5BCAD085-E8A6-8845-BD4E-CB4CCA059FC4}" type="datetimeFigureOut">
               <a:rPr lang="en-US" smtClean="0"/>
-              <a:t>10/6/2026</a:t>
+              <a:t>10/8/2026</a:t>
             </a:fld>
             <a:endParaRPr lang="en-US"/>
           </a:p>
@@ -3120,7 +3148,7 @@
           <a:p>
             <a:fld id="{5BCAD085-E8A6-8845-BD4E-CB4CCA059FC4}" type="datetimeFigureOut">
               <a:rPr lang="en-US" smtClean="0"/>
-              <a:t>10/6/2026</a:t>
+              <a:t>10/8/2026</a:t>
             </a:fld>
             <a:endParaRPr lang="en-US"/>
           </a:p>
@@ -3395,7 +3423,7 @@
           <a:p>
             <a:fld id="{5BCAD085-E8A6-8845-BD4E-CB4CCA059FC4}" type="datetimeFigureOut">
               <a:rPr lang="en-US" smtClean="0"/>
-              <a:t>10/6/2026</a:t>
+              <a:t>10/8/2026</a:t>
             </a:fld>
             <a:endParaRPr lang="en-US"/>
           </a:p>
@@ -3647,7 +3675,7 @@
           <a:p>
             <a:fld id="{5BCAD085-E8A6-8845-BD4E-CB4CCA059FC4}" type="datetimeFigureOut">
               <a:rPr lang="en-US" smtClean="0"/>
-              <a:t>10/6/2026</a:t>
+              <a:t>10/8/2026</a:t>
             </a:fld>
             <a:endParaRPr lang="en-US"/>
           </a:p>
@@ -3858,7 +3886,7 @@
           <a:p>
             <a:fld id="{5BCAD085-E8A6-8845-BD4E-CB4CCA059FC4}" type="datetimeFigureOut">
               <a:rPr lang="en-US" smtClean="0"/>
-              <a:t>10/6/2026</a:t>
+              <a:t>10/8/2026</a:t>
             </a:fld>
             <a:endParaRPr lang="en-US"/>
           </a:p>
@@ -4458,7 +4486,7 @@
         <p:spPr>
           <a:xfrm>
             <a:off x="1097280" y="4297680"/>
-            <a:ext cx="5303520" cy="492443"/>
+            <a:ext cx="5303520" cy="830997"/>
           </a:xfrm>
           <a:prstGeom prst="rect">
             <a:avLst/>
@@ -4497,6 +4525,22 @@
               <a:rPr dirty="0"/>
               <a:t>Deepakraj S</a:t>
             </a:r>
+            <a:endParaRPr lang="en-IN" dirty="0"/>
+          </a:p>
+          <a:p>
+            <a:pPr>
+              <a:defRPr sz="2200" b="1">
+                <a:solidFill>
+                  <a:srgbClr val="FFFFFF"/>
+                </a:solidFill>
+                <a:latin typeface="Trebuchet MS"/>
+              </a:defRPr>
+            </a:pPr>
+            <a:r>
+              <a:rPr lang="en-IN" dirty="0"/>
+              <a:t>Ajai L</a:t>
+            </a:r>
+            <a:endParaRPr dirty="0"/>
           </a:p>
         </p:txBody>
       </p:sp>
@@ -7090,8 +7134,8 @@
         </p:nvSpPr>
         <p:spPr>
           <a:xfrm>
-            <a:off x="960120" y="1828800"/>
-            <a:ext cx="4754880" cy="502920"/>
+            <a:off x="1188720" y="1916222"/>
+            <a:ext cx="4754880" cy="415498"/>
           </a:xfrm>
           <a:prstGeom prst="rect">
             <a:avLst/>
@@ -7113,10 +7157,22 @@
               </a:defRPr>
             </a:pPr>
             <a:r>
+              <a:rPr dirty="0"/>
               <a:t>[THE PROPERTY REGISTRY] </a:t>
             </a:r>
-            <a:r>
-              <a:rPr sz="1600" b="1">
+            <a:endParaRPr lang="en-IN" dirty="0"/>
+          </a:p>
+          <a:p>
+            <a:pPr>
+              <a:defRPr sz="1100" b="1">
+                <a:solidFill>
+                  <a:srgbClr val="00E5FF"/>
+                </a:solidFill>
+                <a:latin typeface="Consolas"/>
+              </a:defRPr>
+            </a:pPr>
+            <a:r>
+              <a:rPr sz="1600" b="1" dirty="0">
                 <a:solidFill>
                   <a:srgbClr val="FFFFFF"/>
                 </a:solidFill>
@@ -7135,7 +7191,7 @@
         </p:nvSpPr>
         <p:spPr>
           <a:xfrm>
-            <a:off x="960120" y="2286000"/>
+            <a:off x="990601" y="2560320"/>
             <a:ext cx="4754880" cy="2971799"/>
           </a:xfrm>
           <a:prstGeom prst="rect">
@@ -7155,7 +7211,7 @@
               </a:spcAft>
             </a:pPr>
             <a:r>
-              <a:rPr sz="1200" b="1">
+              <a:rPr sz="1200" b="1" dirty="0">
                 <a:solidFill>
                   <a:srgbClr val="00E5FF"/>
                 </a:solidFill>
@@ -7164,7 +7220,7 @@
               <a:t>▸ </a:t>
             </a:r>
             <a:r>
-              <a:rPr sz="1200" b="1">
+              <a:rPr sz="1200" b="1" dirty="0">
                 <a:solidFill>
                   <a:srgbClr val="FFFFFF"/>
                 </a:solidFill>
@@ -7173,7 +7229,7 @@
               <a:t>Analogous to Real-Estate Deed: </a:t>
             </a:r>
             <a:r>
-              <a:rPr sz="1200">
+              <a:rPr sz="1200" dirty="0">
                 <a:solidFill>
                   <a:srgbClr val="BAC9E0"/>
                 </a:solidFill>
@@ -7189,7 +7245,7 @@
               </a:spcAft>
             </a:pPr>
             <a:r>
-              <a:rPr sz="1200" b="1">
+              <a:rPr sz="1200" b="1" dirty="0">
                 <a:solidFill>
                   <a:srgbClr val="00E5FF"/>
                 </a:solidFill>
@@ -7198,7 +7254,7 @@
               <a:t>▸ </a:t>
             </a:r>
             <a:r>
-              <a:rPr sz="1200" b="1">
+              <a:rPr sz="1200" b="1" dirty="0">
                 <a:solidFill>
                   <a:srgbClr val="FFFFFF"/>
                 </a:solidFill>
@@ -7207,7 +7263,7 @@
               <a:t>Primary TCP Port 43 Query: </a:t>
             </a:r>
             <a:r>
-              <a:rPr sz="1200">
+              <a:rPr sz="1200" dirty="0">
                 <a:solidFill>
                   <a:srgbClr val="BAC9E0"/>
                 </a:solidFill>
@@ -7223,7 +7279,7 @@
               </a:spcAft>
             </a:pPr>
             <a:r>
-              <a:rPr sz="1200" b="1">
+              <a:rPr sz="1200" b="1" dirty="0">
                 <a:solidFill>
                   <a:srgbClr val="00E5FF"/>
                 </a:solidFill>
@@ -7232,7 +7288,7 @@
               <a:t>▸ </a:t>
             </a:r>
             <a:r>
-              <a:rPr sz="1200" b="1">
+              <a:rPr sz="1200" b="1" dirty="0">
                 <a:solidFill>
                   <a:srgbClr val="FFFFFF"/>
                 </a:solidFill>
@@ -7241,7 +7297,7 @@
               <a:t>Automated HTTPS RDAP Fallback: </a:t>
             </a:r>
             <a:r>
-              <a:rPr sz="1200">
+              <a:rPr sz="1200" dirty="0">
                 <a:solidFill>
                   <a:srgbClr val="BAC9E0"/>
                 </a:solidFill>
@@ -7257,7 +7313,7 @@
               </a:spcAft>
             </a:pPr>
             <a:r>
-              <a:rPr sz="1200" b="1">
+              <a:rPr sz="1200" b="1" dirty="0">
                 <a:solidFill>
                   <a:srgbClr val="00E5FF"/>
                 </a:solidFill>
@@ -7266,7 +7322,7 @@
               <a:t>▸ </a:t>
             </a:r>
             <a:r>
-              <a:rPr sz="1200" b="1">
+              <a:rPr sz="1200" b="1" dirty="0">
                 <a:solidFill>
                   <a:srgbClr val="FFFFFF"/>
                 </a:solidFill>
@@ -7275,7 +7331,7 @@
               <a:t>Key Metadata Extracted: </a:t>
             </a:r>
             <a:r>
-              <a:rPr sz="1200">
+              <a:rPr sz="1200" dirty="0">
                 <a:solidFill>
                   <a:srgbClr val="BAC9E0"/>
                 </a:solidFill>
@@ -7340,8 +7396,8 @@
         </p:nvSpPr>
         <p:spPr>
           <a:xfrm>
-            <a:off x="6446520" y="1828800"/>
-            <a:ext cx="4754880" cy="502920"/>
+            <a:off x="6675120" y="1916222"/>
+            <a:ext cx="4754880" cy="415498"/>
           </a:xfrm>
           <a:prstGeom prst="rect">
             <a:avLst/>
@@ -7363,10 +7419,22 @@
               </a:defRPr>
             </a:pPr>
             <a:r>
+              <a:rPr dirty="0"/>
               <a:t>[THE MASTER PHONEBOOK] </a:t>
             </a:r>
-            <a:r>
-              <a:rPr sz="1600" b="1">
+            <a:endParaRPr lang="en-IN" dirty="0"/>
+          </a:p>
+          <a:p>
+            <a:pPr>
+              <a:defRPr sz="1100" b="1">
+                <a:solidFill>
+                  <a:srgbClr val="00E676"/>
+                </a:solidFill>
+                <a:latin typeface="Consolas"/>
+              </a:defRPr>
+            </a:pPr>
+            <a:r>
+              <a:rPr sz="1600" b="1" dirty="0">
                 <a:solidFill>
                   <a:srgbClr val="FFFFFF"/>
                 </a:solidFill>
@@ -7385,7 +7453,7 @@
         </p:nvSpPr>
         <p:spPr>
           <a:xfrm>
-            <a:off x="6446520" y="2286000"/>
+            <a:off x="6446520" y="2527663"/>
             <a:ext cx="4754880" cy="2971799"/>
           </a:xfrm>
           <a:prstGeom prst="rect">
@@ -7405,7 +7473,7 @@
               </a:spcAft>
             </a:pPr>
             <a:r>
-              <a:rPr sz="1200" b="1">
+              <a:rPr sz="1200" b="1" dirty="0">
                 <a:solidFill>
                   <a:srgbClr val="00E676"/>
                 </a:solidFill>
@@ -7414,7 +7482,7 @@
               <a:t>▸ </a:t>
             </a:r>
             <a:r>
-              <a:rPr sz="1200" b="1">
+              <a:rPr sz="1200" b="1" dirty="0">
                 <a:solidFill>
                   <a:srgbClr val="FFFFFF"/>
                 </a:solidFill>
@@ -7423,7 +7491,7 @@
               <a:t>Translating Names to Infrastructure: </a:t>
             </a:r>
             <a:r>
-              <a:rPr sz="1200">
+              <a:rPr sz="1200" dirty="0">
                 <a:solidFill>
                   <a:srgbClr val="BAC9E0"/>
                 </a:solidFill>
@@ -7439,7 +7507,7 @@
               </a:spcAft>
             </a:pPr>
             <a:r>
-              <a:rPr sz="1200" b="1">
+              <a:rPr sz="1200" b="1" dirty="0">
                 <a:solidFill>
                   <a:srgbClr val="00E676"/>
                 </a:solidFill>
@@ -7448,7 +7516,7 @@
               <a:t>▸ </a:t>
             </a:r>
             <a:r>
-              <a:rPr sz="1200" b="1">
+              <a:rPr sz="1200" b="1" dirty="0">
                 <a:solidFill>
                   <a:srgbClr val="FFFFFF"/>
                 </a:solidFill>
@@ -7457,7 +7525,7 @@
               <a:t>A &amp; AAAA Records: </a:t>
             </a:r>
             <a:r>
-              <a:rPr sz="1200">
+              <a:rPr sz="1200" dirty="0">
                 <a:solidFill>
                   <a:srgbClr val="BAC9E0"/>
                 </a:solidFill>
@@ -7473,7 +7541,7 @@
               </a:spcAft>
             </a:pPr>
             <a:r>
-              <a:rPr sz="1200" b="1">
+              <a:rPr sz="1200" b="1" dirty="0">
                 <a:solidFill>
                   <a:srgbClr val="00E676"/>
                 </a:solidFill>
@@ -7482,7 +7550,7 @@
               <a:t>▸ </a:t>
             </a:r>
             <a:r>
-              <a:rPr sz="1200" b="1">
+              <a:rPr sz="1200" b="1" dirty="0">
                 <a:solidFill>
                   <a:srgbClr val="FFFFFF"/>
                 </a:solidFill>
@@ -7491,7 +7559,7 @@
               <a:t>MX &amp; NS Records: </a:t>
             </a:r>
             <a:r>
-              <a:rPr sz="1200">
+              <a:rPr sz="1200" dirty="0">
                 <a:solidFill>
                   <a:srgbClr val="BAC9E0"/>
                 </a:solidFill>
@@ -7507,7 +7575,7 @@
               </a:spcAft>
             </a:pPr>
             <a:r>
-              <a:rPr sz="1200" b="1">
+              <a:rPr sz="1200" b="1" dirty="0">
                 <a:solidFill>
                   <a:srgbClr val="00E676"/>
                 </a:solidFill>
@@ -7516,7 +7584,7 @@
               <a:t>▸ </a:t>
             </a:r>
             <a:r>
-              <a:rPr sz="1200" b="1">
+              <a:rPr sz="1200" b="1" dirty="0">
                 <a:solidFill>
                   <a:srgbClr val="FFFFFF"/>
                 </a:solidFill>
@@ -7525,7 +7593,7 @@
               <a:t>TXT Security Records: </a:t>
             </a:r>
             <a:r>
-              <a:rPr sz="1200">
+              <a:rPr sz="1200" dirty="0">
                 <a:solidFill>
                   <a:srgbClr val="BAC9E0"/>
                 </a:solidFill>
@@ -7541,7 +7609,7 @@
               </a:spcAft>
             </a:pPr>
             <a:r>
-              <a:rPr sz="1200" b="1">
+              <a:rPr sz="1200" b="1" dirty="0">
                 <a:solidFill>
                   <a:srgbClr val="00E676"/>
                 </a:solidFill>
@@ -7550,7 +7618,7 @@
               <a:t>▸ </a:t>
             </a:r>
             <a:r>
-              <a:rPr sz="1200" b="1">
+              <a:rPr sz="1200" b="1" dirty="0">
                 <a:solidFill>
                   <a:srgbClr val="FFFFFF"/>
                 </a:solidFill>
@@ -7559,7 +7627,7 @@
               <a:t>SOA Records: </a:t>
             </a:r>
             <a:r>
-              <a:rPr sz="1200">
+              <a:rPr sz="1200" dirty="0">
                 <a:solidFill>
                   <a:srgbClr val="BAC9E0"/>
                 </a:solidFill>
@@ -7948,8 +8016,8 @@
         </p:nvSpPr>
         <p:spPr>
           <a:xfrm>
-            <a:off x="960120" y="1828800"/>
-            <a:ext cx="4754880" cy="502920"/>
+            <a:off x="1219353" y="1967281"/>
+            <a:ext cx="4754880" cy="415498"/>
           </a:xfrm>
           <a:prstGeom prst="rect">
             <a:avLst/>
@@ -7971,10 +8039,22 @@
               </a:defRPr>
             </a:pPr>
             <a:r>
+              <a:rPr dirty="0"/>
               <a:t>[ZERO NETWORK FOOTPRINT] </a:t>
             </a:r>
-            <a:r>
-              <a:rPr sz="1600" b="1">
+            <a:endParaRPr lang="en-IN" dirty="0"/>
+          </a:p>
+          <a:p>
+            <a:pPr>
+              <a:defRPr sz="1100" b="1">
+                <a:solidFill>
+                  <a:srgbClr val="00E5FF"/>
+                </a:solidFill>
+                <a:latin typeface="Consolas"/>
+              </a:defRPr>
+            </a:pPr>
+            <a:r>
+              <a:rPr sz="1600" b="1" dirty="0">
                 <a:solidFill>
                   <a:srgbClr val="FFFFFF"/>
                 </a:solidFill>
@@ -7993,7 +8073,7 @@
         </p:nvSpPr>
         <p:spPr>
           <a:xfrm>
-            <a:off x="960120" y="2487547"/>
+            <a:off x="960120" y="2704140"/>
             <a:ext cx="4754880" cy="2971799"/>
           </a:xfrm>
           <a:prstGeom prst="rect">
@@ -8198,8 +8278,8 @@
         </p:nvSpPr>
         <p:spPr>
           <a:xfrm>
-            <a:off x="6446520" y="1828800"/>
-            <a:ext cx="4754880" cy="502920"/>
+            <a:off x="6705295" y="1967281"/>
+            <a:ext cx="4754880" cy="415498"/>
           </a:xfrm>
           <a:prstGeom prst="rect">
             <a:avLst/>
@@ -8221,16 +8301,46 @@
               </a:defRPr>
             </a:pPr>
             <a:r>
+              <a:rPr dirty="0"/>
               <a:t>[HIGH-THROUGHPUT C-ARES] </a:t>
             </a:r>
-            <a:r>
-              <a:rPr sz="1600" b="1">
+            <a:endParaRPr lang="en-IN" dirty="0"/>
+          </a:p>
+          <a:p>
+            <a:pPr>
+              <a:defRPr sz="1100" b="1">
+                <a:solidFill>
+                  <a:srgbClr val="00E676"/>
+                </a:solidFill>
+                <a:latin typeface="Consolas"/>
+              </a:defRPr>
+            </a:pPr>
+            <a:r>
+              <a:rPr sz="1600" b="1" dirty="0">
                 <a:solidFill>
                   <a:srgbClr val="FFFFFF"/>
                 </a:solidFill>
                 <a:latin typeface="Trebuchet MS"/>
               </a:rPr>
-              <a:t>Active: AsyncIO Wordlist Engine</a:t>
+              <a:t>Active: </a:t>
+            </a:r>
+            <a:r>
+              <a:rPr sz="1600" b="1" dirty="0" err="1">
+                <a:solidFill>
+                  <a:srgbClr val="FFFFFF"/>
+                </a:solidFill>
+                <a:latin typeface="Trebuchet MS"/>
+              </a:rPr>
+              <a:t>AsyncIO</a:t>
+            </a:r>
+            <a:r>
+              <a:rPr sz="1600" b="1" dirty="0">
+                <a:solidFill>
+                  <a:srgbClr val="FFFFFF"/>
+                </a:solidFill>
+                <a:latin typeface="Trebuchet MS"/>
+              </a:rPr>
+              <a:t> Wordlist Engine</a:t>
             </a:r>
           </a:p>
         </p:txBody>
@@ -8243,7 +8353,7 @@
         </p:nvSpPr>
         <p:spPr>
           <a:xfrm>
-            <a:off x="6446520" y="2482200"/>
+            <a:off x="6446520" y="2704139"/>
             <a:ext cx="4754880" cy="2971799"/>
           </a:xfrm>
           <a:prstGeom prst="rect">
@@ -8826,8 +8936,8 @@
         </p:nvSpPr>
         <p:spPr>
           <a:xfrm>
-            <a:off x="960120" y="1828800"/>
-            <a:ext cx="4754880" cy="502920"/>
+            <a:off x="1188720" y="1920745"/>
+            <a:ext cx="4754880" cy="415498"/>
           </a:xfrm>
           <a:prstGeom prst="rect">
             <a:avLst/>
@@ -8849,10 +8959,22 @@
               </a:defRPr>
             </a:pPr>
             <a:r>
+              <a:rPr dirty="0"/>
               <a:t>[PORTS 80 &amp; 443] </a:t>
             </a:r>
-            <a:r>
-              <a:rPr sz="1600" b="1">
+            <a:endParaRPr lang="en-IN" dirty="0"/>
+          </a:p>
+          <a:p>
+            <a:pPr>
+              <a:defRPr sz="1100" b="1">
+                <a:solidFill>
+                  <a:srgbClr val="00E5FF"/>
+                </a:solidFill>
+                <a:latin typeface="Consolas"/>
+              </a:defRPr>
+            </a:pPr>
+            <a:r>
+              <a:rPr sz="1600" b="1" dirty="0">
                 <a:solidFill>
                   <a:srgbClr val="FFFFFF"/>
                 </a:solidFill>
@@ -8871,7 +8993,7 @@
         </p:nvSpPr>
         <p:spPr>
           <a:xfrm>
-            <a:off x="960120" y="2286000"/>
+            <a:off x="960120" y="2560320"/>
             <a:ext cx="4754880" cy="2971799"/>
           </a:xfrm>
           <a:prstGeom prst="rect">
@@ -8891,7 +9013,7 @@
               </a:spcAft>
             </a:pPr>
             <a:r>
-              <a:rPr sz="1200" b="1">
+              <a:rPr sz="1200" b="1" dirty="0">
                 <a:solidFill>
                   <a:srgbClr val="00E5FF"/>
                 </a:solidFill>
@@ -8900,7 +9022,7 @@
               <a:t>▸ </a:t>
             </a:r>
             <a:r>
-              <a:rPr sz="1200" b="1">
+              <a:rPr sz="1200" b="1" dirty="0">
                 <a:solidFill>
                   <a:srgbClr val="FFFFFF"/>
                 </a:solidFill>
@@ -8909,13 +9031,31 @@
               <a:t>Non-Blocking Async Client: </a:t>
             </a:r>
             <a:r>
-              <a:rPr sz="1200">
-                <a:solidFill>
-                  <a:srgbClr val="BAC9E0"/>
-                </a:solidFill>
-                <a:latin typeface="Calibri"/>
-              </a:rPr>
-              <a:t>Concurrently probes web endpoints across HTTP (Port 80) and HTTPS (Port 443) via `httpx.AsyncClient`.</a:t>
+              <a:rPr sz="1200" dirty="0">
+                <a:solidFill>
+                  <a:srgbClr val="BAC9E0"/>
+                </a:solidFill>
+                <a:latin typeface="Calibri"/>
+              </a:rPr>
+              <a:t>Concurrently probes web endpoints across HTTP (Port 80) and HTTPS (Port 443) via `</a:t>
+            </a:r>
+            <a:r>
+              <a:rPr sz="1200" dirty="0" err="1">
+                <a:solidFill>
+                  <a:srgbClr val="BAC9E0"/>
+                </a:solidFill>
+                <a:latin typeface="Calibri"/>
+              </a:rPr>
+              <a:t>httpx.AsyncClient</a:t>
+            </a:r>
+            <a:r>
+              <a:rPr sz="1200" dirty="0">
+                <a:solidFill>
+                  <a:srgbClr val="BAC9E0"/>
+                </a:solidFill>
+                <a:latin typeface="Calibri"/>
+              </a:rPr>
+              <a:t>`.</a:t>
             </a:r>
           </a:p>
           <a:p>
@@ -8925,7 +9065,7 @@
               </a:spcAft>
             </a:pPr>
             <a:r>
-              <a:rPr sz="1200" b="1">
+              <a:rPr sz="1200" b="1" dirty="0">
                 <a:solidFill>
                   <a:srgbClr val="00E5FF"/>
                 </a:solidFill>
@@ -8934,7 +9074,7 @@
               <a:t>▸ </a:t>
             </a:r>
             <a:r>
-              <a:rPr sz="1200" b="1">
+              <a:rPr sz="1200" b="1" dirty="0">
                 <a:solidFill>
                   <a:srgbClr val="FFFFFF"/>
                 </a:solidFill>
@@ -8943,7 +9083,7 @@
               <a:t>Self-Signed TLS Resilience: </a:t>
             </a:r>
             <a:r>
-              <a:rPr sz="1200">
+              <a:rPr sz="1200" dirty="0">
                 <a:solidFill>
                   <a:srgbClr val="BAC9E0"/>
                 </a:solidFill>
@@ -8959,7 +9099,7 @@
               </a:spcAft>
             </a:pPr>
             <a:r>
-              <a:rPr sz="1200" b="1">
+              <a:rPr sz="1200" b="1" dirty="0">
                 <a:solidFill>
                   <a:srgbClr val="00E5FF"/>
                 </a:solidFill>
@@ -8968,7 +9108,7 @@
               <a:t>▸ </a:t>
             </a:r>
             <a:r>
-              <a:rPr sz="1200" b="1">
+              <a:rPr sz="1200" b="1" dirty="0">
                 <a:solidFill>
                   <a:srgbClr val="FFFFFF"/>
                 </a:solidFill>
@@ -8977,7 +9117,7 @@
               <a:t>Metadata Harvesting: </a:t>
             </a:r>
             <a:r>
-              <a:rPr sz="1200">
+              <a:rPr sz="1200" dirty="0">
                 <a:solidFill>
                   <a:srgbClr val="BAC9E0"/>
                 </a:solidFill>
@@ -8993,7 +9133,7 @@
               </a:spcAft>
             </a:pPr>
             <a:r>
-              <a:rPr sz="1200" b="1">
+              <a:rPr sz="1200" b="1" dirty="0">
                 <a:solidFill>
                   <a:srgbClr val="00E5FF"/>
                 </a:solidFill>
@@ -9002,7 +9142,7 @@
               <a:t>▸ </a:t>
             </a:r>
             <a:r>
-              <a:rPr sz="1200" b="1">
+              <a:rPr sz="1200" b="1" dirty="0">
                 <a:solidFill>
                   <a:srgbClr val="FFFFFF"/>
                 </a:solidFill>
@@ -9011,7 +9151,7 @@
               <a:t>HTML Title Extraction: </a:t>
             </a:r>
             <a:r>
-              <a:rPr sz="1200">
+              <a:rPr sz="1200" dirty="0">
                 <a:solidFill>
                   <a:srgbClr val="BAC9E0"/>
                 </a:solidFill>
@@ -9076,8 +9216,8 @@
         </p:nvSpPr>
         <p:spPr>
           <a:xfrm>
-            <a:off x="6446520" y="1828800"/>
-            <a:ext cx="4754880" cy="502920"/>
+            <a:off x="6675120" y="1920745"/>
+            <a:ext cx="4754880" cy="415498"/>
           </a:xfrm>
           <a:prstGeom prst="rect">
             <a:avLst/>
@@ -9099,10 +9239,22 @@
               </a:defRPr>
             </a:pPr>
             <a:r>
+              <a:rPr dirty="0"/>
               <a:t>[HIGH SEVERITY ALERT] </a:t>
             </a:r>
-            <a:r>
-              <a:rPr sz="1600" b="1">
+            <a:endParaRPr lang="en-IN" dirty="0"/>
+          </a:p>
+          <a:p>
+            <a:pPr>
+              <a:defRPr sz="1100" b="1">
+                <a:solidFill>
+                  <a:srgbClr val="FF4081"/>
+                </a:solidFill>
+                <a:latin typeface="Consolas"/>
+              </a:defRPr>
+            </a:pPr>
+            <a:r>
+              <a:rPr sz="1600" b="1" dirty="0">
                 <a:solidFill>
                   <a:srgbClr val="FFFFFF"/>
                 </a:solidFill>
@@ -9121,7 +9273,7 @@
         </p:nvSpPr>
         <p:spPr>
           <a:xfrm>
-            <a:off x="6446520" y="2286000"/>
+            <a:off x="6477002" y="2543992"/>
             <a:ext cx="4754880" cy="2971799"/>
           </a:xfrm>
           <a:prstGeom prst="rect">
@@ -9141,7 +9293,7 @@
               </a:spcAft>
             </a:pPr>
             <a:r>
-              <a:rPr sz="1200" b="1">
+              <a:rPr sz="1200" b="1" dirty="0">
                 <a:solidFill>
                   <a:srgbClr val="FF4081"/>
                 </a:solidFill>
@@ -9150,7 +9302,7 @@
               <a:t>▸ </a:t>
             </a:r>
             <a:r>
-              <a:rPr sz="1200" b="1">
+              <a:rPr sz="1200" b="1" dirty="0">
                 <a:solidFill>
                   <a:srgbClr val="FFFFFF"/>
                 </a:solidFill>
@@ -9159,7 +9311,7 @@
               <a:t>The Mechanics: </a:t>
             </a:r>
             <a:r>
-              <a:rPr sz="1200">
+              <a:rPr sz="1200" dirty="0">
                 <a:solidFill>
                   <a:srgbClr val="BAC9E0"/>
                 </a:solidFill>
@@ -9175,7 +9327,7 @@
               </a:spcAft>
             </a:pPr>
             <a:r>
-              <a:rPr sz="1200" b="1">
+              <a:rPr sz="1200" b="1" dirty="0">
                 <a:solidFill>
                   <a:srgbClr val="FF4081"/>
                 </a:solidFill>
@@ -9184,7 +9336,7 @@
               <a:t>▸ </a:t>
             </a:r>
             <a:r>
-              <a:rPr sz="1200" b="1">
+              <a:rPr sz="1200" b="1" dirty="0">
                 <a:solidFill>
                   <a:srgbClr val="FFFFFF"/>
                 </a:solidFill>
@@ -9193,7 +9345,7 @@
               <a:t>Fingerprint Matching: </a:t>
             </a:r>
             <a:r>
-              <a:rPr sz="1200">
+              <a:rPr sz="1200" dirty="0">
                 <a:solidFill>
                   <a:srgbClr val="BAC9E0"/>
                 </a:solidFill>
@@ -9209,7 +9361,7 @@
               </a:spcAft>
             </a:pPr>
             <a:r>
-              <a:rPr sz="1200" b="1">
+              <a:rPr sz="1200" b="1" dirty="0">
                 <a:solidFill>
                   <a:srgbClr val="FF4081"/>
                 </a:solidFill>
@@ -9218,7 +9370,7 @@
               <a:t>▸ </a:t>
             </a:r>
             <a:r>
-              <a:rPr sz="1200" b="1">
+              <a:rPr sz="1200" b="1" dirty="0">
                 <a:solidFill>
                   <a:srgbClr val="FFFFFF"/>
                 </a:solidFill>
@@ -9227,13 +9379,31 @@
               <a:t>Multi-Provider Signatures: </a:t>
             </a:r>
             <a:r>
-              <a:rPr sz="1200">
-                <a:solidFill>
-                  <a:srgbClr val="BAC9E0"/>
-                </a:solidFill>
-                <a:latin typeface="Calibri"/>
-              </a:rPr>
-              <a:t>Detects AWS S3 (`NoSuchBucket`), GitHub Pages (`There isn't a GitHub Pages site here`), Heroku (`No such app`), Azure, Shopify, and Fastly.</a:t>
+              <a:rPr sz="1200" dirty="0">
+                <a:solidFill>
+                  <a:srgbClr val="BAC9E0"/>
+                </a:solidFill>
+                <a:latin typeface="Calibri"/>
+              </a:rPr>
+              <a:t>Detects AWS S3 (`</a:t>
+            </a:r>
+            <a:r>
+              <a:rPr sz="1200" dirty="0" err="1">
+                <a:solidFill>
+                  <a:srgbClr val="BAC9E0"/>
+                </a:solidFill>
+                <a:latin typeface="Calibri"/>
+              </a:rPr>
+              <a:t>NoSuchBucket</a:t>
+            </a:r>
+            <a:r>
+              <a:rPr sz="1200" dirty="0">
+                <a:solidFill>
+                  <a:srgbClr val="BAC9E0"/>
+                </a:solidFill>
+                <a:latin typeface="Calibri"/>
+              </a:rPr>
+              <a:t>`), GitHub Pages (`There isn't a GitHub Pages site here`), Heroku (`No such app`), Azure, Shopify, and Fastly.</a:t>
             </a:r>
           </a:p>
           <a:p>
@@ -9243,7 +9413,7 @@
               </a:spcAft>
             </a:pPr>
             <a:r>
-              <a:rPr sz="1200" b="1">
+              <a:rPr sz="1200" b="1" dirty="0">
                 <a:solidFill>
                   <a:srgbClr val="FF4081"/>
                 </a:solidFill>
@@ -9252,7 +9422,7 @@
               <a:t>▸ </a:t>
             </a:r>
             <a:r>
-              <a:rPr sz="1200" b="1">
+              <a:rPr sz="1200" b="1" dirty="0">
                 <a:solidFill>
                   <a:srgbClr val="FFFFFF"/>
                 </a:solidFill>
@@ -9261,7 +9431,7 @@
               <a:t>Instant Alerting: </a:t>
             </a:r>
             <a:r>
-              <a:rPr sz="1200">
+              <a:rPr sz="1200" dirty="0">
                 <a:solidFill>
                   <a:srgbClr val="BAC9E0"/>
                 </a:solidFill>
@@ -11972,8 +12142,8 @@
         </p:nvSpPr>
         <p:spPr>
           <a:xfrm>
-            <a:off x="960120" y="1828800"/>
-            <a:ext cx="4754880" cy="502920"/>
+            <a:off x="1158545" y="1911323"/>
+            <a:ext cx="4754880" cy="415498"/>
           </a:xfrm>
           <a:prstGeom prst="rect">
             <a:avLst/>
@@ -11995,10 +12165,22 @@
               </a:defRPr>
             </a:pPr>
             <a:r>
+              <a:rPr dirty="0"/>
               <a:t>[PROJECT SUMMARY] </a:t>
             </a:r>
-            <a:r>
-              <a:rPr sz="1600" b="1">
+            <a:endParaRPr lang="en-IN" dirty="0"/>
+          </a:p>
+          <a:p>
+            <a:pPr>
+              <a:defRPr sz="1100" b="1">
+                <a:solidFill>
+                  <a:srgbClr val="00E5FF"/>
+                </a:solidFill>
+                <a:latin typeface="Consolas"/>
+              </a:defRPr>
+            </a:pPr>
+            <a:r>
+              <a:rPr sz="1600" b="1" dirty="0">
                 <a:solidFill>
                   <a:srgbClr val="FFFFFF"/>
                 </a:solidFill>
@@ -12017,7 +12199,7 @@
         </p:nvSpPr>
         <p:spPr>
           <a:xfrm>
-            <a:off x="960120" y="2286000"/>
+            <a:off x="960120" y="2674620"/>
             <a:ext cx="4754880" cy="2971799"/>
           </a:xfrm>
           <a:prstGeom prst="rect">
@@ -12037,7 +12219,7 @@
               </a:spcAft>
             </a:pPr>
             <a:r>
-              <a:rPr sz="1200" b="1">
+              <a:rPr sz="1200" b="1" dirty="0">
                 <a:solidFill>
                   <a:srgbClr val="00E5FF"/>
                 </a:solidFill>
@@ -12046,7 +12228,7 @@
               <a:t>▸ </a:t>
             </a:r>
             <a:r>
-              <a:rPr sz="1200" b="1">
+              <a:rPr sz="1200" b="1" dirty="0">
                 <a:solidFill>
                   <a:srgbClr val="FFFFFF"/>
                 </a:solidFill>
@@ -12055,7 +12237,7 @@
               <a:t>Full Attack Surface Coverage: </a:t>
             </a:r>
             <a:r>
-              <a:rPr sz="1200">
+              <a:rPr sz="1200" dirty="0">
                 <a:solidFill>
                   <a:srgbClr val="BAC9E0"/>
                 </a:solidFill>
@@ -12071,7 +12253,7 @@
               </a:spcAft>
             </a:pPr>
             <a:r>
-              <a:rPr sz="1200" b="1">
+              <a:rPr sz="1200" b="1" dirty="0">
                 <a:solidFill>
                   <a:srgbClr val="00E5FF"/>
                 </a:solidFill>
@@ -12080,7 +12262,7 @@
               <a:t>▸ </a:t>
             </a:r>
             <a:r>
-              <a:rPr sz="1200" b="1">
+              <a:rPr sz="1200" b="1" dirty="0">
                 <a:solidFill>
                   <a:srgbClr val="FFFFFF"/>
                 </a:solidFill>
@@ -12089,13 +12271,58 @@
               <a:t>High-Throughput Concurrency: </a:t>
             </a:r>
             <a:r>
-              <a:rPr sz="1200">
-                <a:solidFill>
-                  <a:srgbClr val="BAC9E0"/>
-                </a:solidFill>
-                <a:latin typeface="Calibri"/>
-              </a:rPr>
-              <a:t>AsyncIO event loop + aiodns + httpx delivers enterprise-grade scalability with bounded memory usage.</a:t>
+              <a:rPr sz="1200" dirty="0" err="1">
+                <a:solidFill>
+                  <a:srgbClr val="BAC9E0"/>
+                </a:solidFill>
+                <a:latin typeface="Calibri"/>
+              </a:rPr>
+              <a:t>AsyncIO</a:t>
+            </a:r>
+            <a:r>
+              <a:rPr sz="1200" dirty="0">
+                <a:solidFill>
+                  <a:srgbClr val="BAC9E0"/>
+                </a:solidFill>
+                <a:latin typeface="Calibri"/>
+              </a:rPr>
+              <a:t> event loop + </a:t>
+            </a:r>
+            <a:r>
+              <a:rPr sz="1200" dirty="0" err="1">
+                <a:solidFill>
+                  <a:srgbClr val="BAC9E0"/>
+                </a:solidFill>
+                <a:latin typeface="Calibri"/>
+              </a:rPr>
+              <a:t>aiodns</a:t>
+            </a:r>
+            <a:r>
+              <a:rPr sz="1200" dirty="0">
+                <a:solidFill>
+                  <a:srgbClr val="BAC9E0"/>
+                </a:solidFill>
+                <a:latin typeface="Calibri"/>
+              </a:rPr>
+              <a:t> + </a:t>
+            </a:r>
+            <a:r>
+              <a:rPr sz="1200" dirty="0" err="1">
+                <a:solidFill>
+                  <a:srgbClr val="BAC9E0"/>
+                </a:solidFill>
+                <a:latin typeface="Calibri"/>
+              </a:rPr>
+              <a:t>httpx</a:t>
+            </a:r>
+            <a:r>
+              <a:rPr sz="1200" dirty="0">
+                <a:solidFill>
+                  <a:srgbClr val="BAC9E0"/>
+                </a:solidFill>
+                <a:latin typeface="Calibri"/>
+              </a:rPr>
+              <a:t> delivers enterprise-grade scalability with bounded memory usage.</a:t>
             </a:r>
           </a:p>
           <a:p>
@@ -12105,7 +12332,7 @@
               </a:spcAft>
             </a:pPr>
             <a:r>
-              <a:rPr sz="1200" b="1">
+              <a:rPr sz="1200" b="1" dirty="0">
                 <a:solidFill>
                   <a:srgbClr val="00E5FF"/>
                 </a:solidFill>
@@ -12114,7 +12341,7 @@
               <a:t>▸ </a:t>
             </a:r>
             <a:r>
-              <a:rPr sz="1200" b="1">
+              <a:rPr sz="1200" b="1" dirty="0">
                 <a:solidFill>
                   <a:srgbClr val="FFFFFF"/>
                 </a:solidFill>
@@ -12123,7 +12350,7 @@
               <a:t>Actionable Vulnerability Impact: </a:t>
             </a:r>
             <a:r>
-              <a:rPr sz="1200">
+              <a:rPr sz="1200" dirty="0">
                 <a:solidFill>
                   <a:srgbClr val="BAC9E0"/>
                 </a:solidFill>
@@ -12139,7 +12366,7 @@
               </a:spcAft>
             </a:pPr>
             <a:r>
-              <a:rPr sz="1200" b="1">
+              <a:rPr sz="1200" b="1" dirty="0">
                 <a:solidFill>
                   <a:srgbClr val="00E5FF"/>
                 </a:solidFill>
@@ -12148,7 +12375,7 @@
               <a:t>▸ </a:t>
             </a:r>
             <a:r>
-              <a:rPr sz="1200" b="1">
+              <a:rPr sz="1200" b="1" dirty="0">
                 <a:solidFill>
                   <a:srgbClr val="FFFFFF"/>
                 </a:solidFill>
@@ -12157,13 +12384,31 @@
               <a:t>Software Engineering Best Practices: </a:t>
             </a:r>
             <a:r>
-              <a:rPr sz="1200">
-                <a:solidFill>
-                  <a:srgbClr val="BAC9E0"/>
-                </a:solidFill>
-                <a:latin typeface="Calibri"/>
-              </a:rPr>
-              <a:t>Clean decoupled architecture, typed dataclasses, resilient fallbacks, and 100% offline mocked unit tests.</a:t>
+              <a:rPr sz="1200" dirty="0">
+                <a:solidFill>
+                  <a:srgbClr val="BAC9E0"/>
+                </a:solidFill>
+                <a:latin typeface="Calibri"/>
+              </a:rPr>
+              <a:t>Clean decoupled architecture, typed </a:t>
+            </a:r>
+            <a:r>
+              <a:rPr sz="1200" dirty="0" err="1">
+                <a:solidFill>
+                  <a:srgbClr val="BAC9E0"/>
+                </a:solidFill>
+                <a:latin typeface="Calibri"/>
+              </a:rPr>
+              <a:t>dataclasses</a:t>
+            </a:r>
+            <a:r>
+              <a:rPr sz="1200" dirty="0">
+                <a:solidFill>
+                  <a:srgbClr val="BAC9E0"/>
+                </a:solidFill>
+                <a:latin typeface="Calibri"/>
+              </a:rPr>
+              <a:t>, resilient fallbacks, and 100% offline mocked unit tests.</a:t>
             </a:r>
           </a:p>
         </p:txBody>
@@ -12222,8 +12467,8 @@
         </p:nvSpPr>
         <p:spPr>
           <a:xfrm>
-            <a:off x="6446520" y="1828800"/>
-            <a:ext cx="4754880" cy="502920"/>
+            <a:off x="6675120" y="1911323"/>
+            <a:ext cx="4754880" cy="415498"/>
           </a:xfrm>
           <a:prstGeom prst="rect">
             <a:avLst/>
@@ -12245,10 +12490,22 @@
               </a:defRPr>
             </a:pPr>
             <a:r>
+              <a:rPr dirty="0"/>
               <a:t>[TECH STACK &amp; REPO] </a:t>
             </a:r>
-            <a:r>
-              <a:rPr sz="1600" b="1">
+            <a:endParaRPr lang="en-IN" dirty="0"/>
+          </a:p>
+          <a:p>
+            <a:pPr>
+              <a:defRPr sz="1100" b="1">
+                <a:solidFill>
+                  <a:srgbClr val="00E676"/>
+                </a:solidFill>
+                <a:latin typeface="Consolas"/>
+              </a:defRPr>
+            </a:pPr>
+            <a:r>
+              <a:rPr sz="1600" b="1" dirty="0">
                 <a:solidFill>
                   <a:srgbClr val="FFFFFF"/>
                 </a:solidFill>
@@ -12267,8 +12524,8 @@
         </p:nvSpPr>
         <p:spPr>
           <a:xfrm>
-            <a:off x="6446520" y="2286000"/>
-            <a:ext cx="4754880" cy="2971799"/>
+            <a:off x="6446520" y="2674620"/>
+            <a:ext cx="4754880" cy="1990288"/>
           </a:xfrm>
           <a:prstGeom prst="rect">
             <a:avLst/>
@@ -12287,7 +12544,7 @@
               </a:spcAft>
             </a:pPr>
             <a:r>
-              <a:rPr sz="1200" b="1">
+              <a:rPr sz="1200" b="1" dirty="0">
                 <a:solidFill>
                   <a:srgbClr val="00E676"/>
                 </a:solidFill>
@@ -12296,7 +12553,7 @@
               <a:t>▸ </a:t>
             </a:r>
             <a:r>
-              <a:rPr sz="1200" b="1">
+              <a:rPr sz="1200" b="1" dirty="0">
                 <a:solidFill>
                   <a:srgbClr val="FFFFFF"/>
                 </a:solidFill>
@@ -12305,13 +12562,31 @@
               <a:t>Core Language: </a:t>
             </a:r>
             <a:r>
-              <a:rPr sz="1200">
-                <a:solidFill>
-                  <a:srgbClr val="BAC9E0"/>
-                </a:solidFill>
-                <a:latin typeface="Calibri"/>
-              </a:rPr>
-              <a:t>Python 3.9+ (Modern type hinting, AsyncIO event loop)</a:t>
+              <a:rPr sz="1200" dirty="0">
+                <a:solidFill>
+                  <a:srgbClr val="BAC9E0"/>
+                </a:solidFill>
+                <a:latin typeface="Calibri"/>
+              </a:rPr>
+              <a:t>Python 3.9+ (Modern type hinting, </a:t>
+            </a:r>
+            <a:r>
+              <a:rPr sz="1200" dirty="0" err="1">
+                <a:solidFill>
+                  <a:srgbClr val="BAC9E0"/>
+                </a:solidFill>
+                <a:latin typeface="Calibri"/>
+              </a:rPr>
+              <a:t>AsyncIO</a:t>
+            </a:r>
+            <a:r>
+              <a:rPr sz="1200" dirty="0">
+                <a:solidFill>
+                  <a:srgbClr val="BAC9E0"/>
+                </a:solidFill>
+                <a:latin typeface="Calibri"/>
+              </a:rPr>
+              <a:t> event loop)</a:t>
             </a:r>
           </a:p>
           <a:p>
@@ -12321,7 +12596,7 @@
               </a:spcAft>
             </a:pPr>
             <a:r>
-              <a:rPr sz="1200" b="1">
+              <a:rPr sz="1200" b="1" dirty="0">
                 <a:solidFill>
                   <a:srgbClr val="00E676"/>
                 </a:solidFill>
@@ -12330,7 +12605,7 @@
               <a:t>▸ </a:t>
             </a:r>
             <a:r>
-              <a:rPr sz="1200" b="1">
+              <a:rPr sz="1200" b="1" dirty="0">
                 <a:solidFill>
                   <a:srgbClr val="FFFFFF"/>
                 </a:solidFill>
@@ -12339,13 +12614,67 @@
               <a:t>Asynchronous Networking: </a:t>
             </a:r>
             <a:r>
-              <a:rPr sz="1200">
-                <a:solidFill>
-                  <a:srgbClr val="BAC9E0"/>
-                </a:solidFill>
-                <a:latin typeface="Calibri"/>
-              </a:rPr>
-              <a:t>`aiodns` (C-ares DNS resolver), `httpx` (Async HTTP/2 client)</a:t>
+              <a:rPr sz="1200" dirty="0">
+                <a:solidFill>
+                  <a:srgbClr val="BAC9E0"/>
+                </a:solidFill>
+                <a:latin typeface="Calibri"/>
+              </a:rPr>
+              <a:t>`</a:t>
+            </a:r>
+            <a:r>
+              <a:rPr sz="1200" dirty="0" err="1">
+                <a:solidFill>
+                  <a:srgbClr val="BAC9E0"/>
+                </a:solidFill>
+                <a:latin typeface="Calibri"/>
+              </a:rPr>
+              <a:t>aiodns</a:t>
+            </a:r>
+            <a:r>
+              <a:rPr sz="1200" dirty="0">
+                <a:solidFill>
+                  <a:srgbClr val="BAC9E0"/>
+                </a:solidFill>
+                <a:latin typeface="Calibri"/>
+              </a:rPr>
+              <a:t>` (C-</a:t>
+            </a:r>
+            <a:r>
+              <a:rPr sz="1200" dirty="0" err="1">
+                <a:solidFill>
+                  <a:srgbClr val="BAC9E0"/>
+                </a:solidFill>
+                <a:latin typeface="Calibri"/>
+              </a:rPr>
+              <a:t>ares</a:t>
+            </a:r>
+            <a:r>
+              <a:rPr sz="1200" dirty="0">
+                <a:solidFill>
+                  <a:srgbClr val="BAC9E0"/>
+                </a:solidFill>
+                <a:latin typeface="Calibri"/>
+              </a:rPr>
+              <a:t> DNS resolver), `</a:t>
+            </a:r>
+            <a:r>
+              <a:rPr sz="1200" dirty="0" err="1">
+                <a:solidFill>
+                  <a:srgbClr val="BAC9E0"/>
+                </a:solidFill>
+                <a:latin typeface="Calibri"/>
+              </a:rPr>
+              <a:t>httpx</a:t>
+            </a:r>
+            <a:r>
+              <a:rPr sz="1200" dirty="0">
+                <a:solidFill>
+                  <a:srgbClr val="BAC9E0"/>
+                </a:solidFill>
+                <a:latin typeface="Calibri"/>
+              </a:rPr>
+              <a:t>` (Async HTTP/2 client)</a:t>
             </a:r>
           </a:p>
           <a:p>
@@ -12355,7 +12684,7 @@
               </a:spcAft>
             </a:pPr>
             <a:r>
-              <a:rPr sz="1200" b="1">
+              <a:rPr sz="1200" b="1" dirty="0">
                 <a:solidFill>
                   <a:srgbClr val="00E676"/>
                 </a:solidFill>
@@ -12364,7 +12693,7 @@
               <a:t>▸ </a:t>
             </a:r>
             <a:r>
-              <a:rPr sz="1200" b="1">
+              <a:rPr sz="1200" b="1" dirty="0">
                 <a:solidFill>
                   <a:srgbClr val="FFFFFF"/>
                 </a:solidFill>
@@ -12373,13 +12702,49 @@
               <a:t>DNS &amp; Network Libraries: </a:t>
             </a:r>
             <a:r>
-              <a:rPr sz="1200">
-                <a:solidFill>
-                  <a:srgbClr val="BAC9E0"/>
-                </a:solidFill>
-                <a:latin typeface="Calibri"/>
-              </a:rPr>
-              <a:t>`dnspython`, `python-whois`, ICANN RESTful RDAP fallback</a:t>
+              <a:rPr sz="1200" dirty="0">
+                <a:solidFill>
+                  <a:srgbClr val="BAC9E0"/>
+                </a:solidFill>
+                <a:latin typeface="Calibri"/>
+              </a:rPr>
+              <a:t>`</a:t>
+            </a:r>
+            <a:r>
+              <a:rPr sz="1200" dirty="0" err="1">
+                <a:solidFill>
+                  <a:srgbClr val="BAC9E0"/>
+                </a:solidFill>
+                <a:latin typeface="Calibri"/>
+              </a:rPr>
+              <a:t>dnspython</a:t>
+            </a:r>
+            <a:r>
+              <a:rPr sz="1200" dirty="0">
+                <a:solidFill>
+                  <a:srgbClr val="BAC9E0"/>
+                </a:solidFill>
+                <a:latin typeface="Calibri"/>
+              </a:rPr>
+              <a:t>`, `python-</a:t>
+            </a:r>
+            <a:r>
+              <a:rPr sz="1200" dirty="0" err="1">
+                <a:solidFill>
+                  <a:srgbClr val="BAC9E0"/>
+                </a:solidFill>
+                <a:latin typeface="Calibri"/>
+              </a:rPr>
+              <a:t>whois</a:t>
+            </a:r>
+            <a:r>
+              <a:rPr sz="1200" dirty="0">
+                <a:solidFill>
+                  <a:srgbClr val="BAC9E0"/>
+                </a:solidFill>
+                <a:latin typeface="Calibri"/>
+              </a:rPr>
+              <a:t>`, ICANN RESTful RDAP fallback</a:t>
             </a:r>
           </a:p>
           <a:p>
@@ -12389,7 +12754,7 @@
               </a:spcAft>
             </a:pPr>
             <a:r>
-              <a:rPr sz="1200" b="1">
+              <a:rPr sz="1200" b="1" dirty="0">
                 <a:solidFill>
                   <a:srgbClr val="00E676"/>
                 </a:solidFill>
@@ -12398,7 +12763,7 @@
               <a:t>▸ </a:t>
             </a:r>
             <a:r>
-              <a:rPr sz="1200" b="1">
+              <a:rPr sz="1200" b="1" dirty="0">
                 <a:solidFill>
                   <a:srgbClr val="FFFFFF"/>
                 </a:solidFill>
@@ -12407,13 +12772,49 @@
               <a:t>Testing &amp; Code Quality: </a:t>
             </a:r>
             <a:r>
-              <a:rPr sz="1200">
-                <a:solidFill>
-                  <a:srgbClr val="BAC9E0"/>
-                </a:solidFill>
-                <a:latin typeface="Calibri"/>
-              </a:rPr>
-              <a:t>`unittest`, `unittest.mock.AsyncMock`, `flake8`, `black`</a:t>
+              <a:rPr sz="1200" dirty="0">
+                <a:solidFill>
+                  <a:srgbClr val="BAC9E0"/>
+                </a:solidFill>
+                <a:latin typeface="Calibri"/>
+              </a:rPr>
+              <a:t>`</a:t>
+            </a:r>
+            <a:r>
+              <a:rPr sz="1200" dirty="0" err="1">
+                <a:solidFill>
+                  <a:srgbClr val="BAC9E0"/>
+                </a:solidFill>
+                <a:latin typeface="Calibri"/>
+              </a:rPr>
+              <a:t>unittest</a:t>
+            </a:r>
+            <a:r>
+              <a:rPr sz="1200" dirty="0">
+                <a:solidFill>
+                  <a:srgbClr val="BAC9E0"/>
+                </a:solidFill>
+                <a:latin typeface="Calibri"/>
+              </a:rPr>
+              <a:t>`, `</a:t>
+            </a:r>
+            <a:r>
+              <a:rPr sz="1200" dirty="0" err="1">
+                <a:solidFill>
+                  <a:srgbClr val="BAC9E0"/>
+                </a:solidFill>
+                <a:latin typeface="Calibri"/>
+              </a:rPr>
+              <a:t>unittest.mock.AsyncMock</a:t>
+            </a:r>
+            <a:r>
+              <a:rPr sz="1200" dirty="0">
+                <a:solidFill>
+                  <a:srgbClr val="BAC9E0"/>
+                </a:solidFill>
+                <a:latin typeface="Calibri"/>
+              </a:rPr>
+              <a:t>`, `flake8`, `black`</a:t>
             </a:r>
           </a:p>
           <a:p>
@@ -12423,7 +12824,7 @@
               </a:spcAft>
             </a:pPr>
             <a:r>
-              <a:rPr sz="1200" b="1">
+              <a:rPr sz="1200" b="1" dirty="0">
                 <a:solidFill>
                   <a:srgbClr val="00E676"/>
                 </a:solidFill>
@@ -12432,7 +12833,7 @@
               <a:t>▸ </a:t>
             </a:r>
             <a:r>
-              <a:rPr sz="1200" b="1">
+              <a:rPr sz="1200" b="1" dirty="0">
                 <a:solidFill>
                   <a:srgbClr val="FFFFFF"/>
                 </a:solidFill>
@@ -12441,13 +12842,49 @@
               <a:t>Presenter: </a:t>
             </a:r>
             <a:r>
-              <a:rPr sz="1200">
-                <a:solidFill>
-                  <a:srgbClr val="BAC9E0"/>
-                </a:solidFill>
-                <a:latin typeface="Calibri"/>
-              </a:rPr>
-              <a:t>Deepakraj S  |  GitHub: OmniRecon Project</a:t>
+              <a:rPr sz="1200" dirty="0">
+                <a:solidFill>
+                  <a:srgbClr val="BAC9E0"/>
+                </a:solidFill>
+                <a:latin typeface="Calibri"/>
+              </a:rPr>
+              <a:t>Deepakraj S </a:t>
+            </a:r>
+            <a:r>
+              <a:rPr lang="en-IN" sz="1200" dirty="0">
+                <a:solidFill>
+                  <a:srgbClr val="BAC9E0"/>
+                </a:solidFill>
+                <a:latin typeface="Calibri"/>
+              </a:rPr>
+              <a:t>and Ajai L</a:t>
+            </a:r>
+            <a:r>
+              <a:rPr sz="1200" dirty="0">
+                <a:solidFill>
+                  <a:srgbClr val="BAC9E0"/>
+                </a:solidFill>
+                <a:latin typeface="Calibri"/>
+              </a:rPr>
+              <a:t> |  GitHub: </a:t>
+            </a:r>
+            <a:r>
+              <a:rPr sz="1200" dirty="0" err="1">
+                <a:solidFill>
+                  <a:srgbClr val="BAC9E0"/>
+                </a:solidFill>
+                <a:latin typeface="Calibri"/>
+              </a:rPr>
+              <a:t>OmniRecon</a:t>
+            </a:r>
+            <a:r>
+              <a:rPr sz="1200" dirty="0">
+                <a:solidFill>
+                  <a:srgbClr val="BAC9E0"/>
+                </a:solidFill>
+                <a:latin typeface="Calibri"/>
+              </a:rPr>
+              <a:t> Project</a:t>
             </a:r>
           </a:p>
         </p:txBody>

</xml_diff>